<commit_message>
docs: add formal 5-chapter final submission report PDF and update PPT slides with GitHub repo link
</commit_message>
<xml_diff>
--- a/Presentation.pptx
+++ b/Presentation.pptx
@@ -10,6 +10,8 @@
     <p:sldId id="258" r:id="rId9"/>
     <p:sldId id="259" r:id="rId10"/>
     <p:sldId id="260" r:id="rId11"/>
+    <p:sldId id="261" r:id="rId12"/>
+    <p:sldId id="262" r:id="rId13"/>
   </p:sldIdLst>
   <p:sldSz cx="9144000" cy="6858000" type="screen4x3"/>
   <p:notesSz cx="6858000" cy="9144000"/>
@@ -3394,6 +3396,174 @@
 </file>
 
 <file path=ppt/slides/slide5.xml><?xml version="1.0" encoding="utf-8"?>
+<p:sld xmlns:a="http://schemas.openxmlformats.org/drawingml/2006/main" xmlns:p="http://schemas.openxmlformats.org/presentationml/2006/main" xmlns:r="http://schemas.openxmlformats.org/officeDocument/2006/relationships">
+  <p:cSld>
+    <p:spTree>
+      <p:nvGrpSpPr>
+        <p:cNvPr id="1" name=""/>
+        <p:cNvGrpSpPr/>
+        <p:nvPr/>
+      </p:nvGrpSpPr>
+      <p:grpSpPr/>
+      <p:sp>
+        <p:nvSpPr>
+          <p:cNvPr id="2" name="Title 1"/>
+          <p:cNvSpPr>
+            <a:spLocks noGrp="1"/>
+          </p:cNvSpPr>
+          <p:nvPr>
+            <p:ph type="title"/>
+          </p:nvPr>
+        </p:nvSpPr>
+        <p:spPr/>
+        <p:txBody>
+          <a:bodyPr/>
+          <a:lstStyle/>
+          <a:p>
+            <a:r>
+              <a:t>Live Runtime Verification &amp; QA</a:t>
+            </a:r>
+          </a:p>
+        </p:txBody>
+      </p:sp>
+      <p:sp>
+        <p:nvSpPr>
+          <p:cNvPr id="3" name="Content Placeholder 2"/>
+          <p:cNvSpPr>
+            <a:spLocks noGrp="1"/>
+          </p:cNvSpPr>
+          <p:nvPr>
+            <p:ph idx="1"/>
+          </p:nvPr>
+        </p:nvSpPr>
+        <p:spPr/>
+        <p:txBody>
+          <a:bodyPr/>
+          <a:lstStyle/>
+          <a:p>
+            <a:r>
+              <a:t>Empirical Proof of Functionality</a:t>
+            </a:r>
+          </a:p>
+          <a:p>
+            <a:pPr lvl="1"/>
+            <a:r>
+              <a:t>API Test Suite: Verified POST /predict endpoint live on HTTP port 8000.</a:t>
+            </a:r>
+          </a:p>
+          <a:p>
+            <a:pPr lvl="1"/>
+            <a:r>
+              <a:t>HTTP 200 OK: Valid JPEG/PNG leaf images return structured JSON with confidence tiers and treatments.</a:t>
+            </a:r>
+          </a:p>
+          <a:p>
+            <a:pPr lvl="1"/>
+            <a:r>
+              <a:t>HTTP 400 Bad Request: Successfully intercepts and rejects invalid text files and &gt;5MB oversized images.</a:t>
+            </a:r>
+          </a:p>
+          <a:p>
+            <a:pPr lvl="1"/>
+            <a:r>
+              <a:t>Dependency Audit: 100% clean package imports (FastAPI, PyTorch, Uvicorn, Pillow, Pydantic).</a:t>
+            </a:r>
+          </a:p>
+        </p:txBody>
+      </p:sp>
+    </p:spTree>
+  </p:cSld>
+  <p:clrMapOvr>
+    <a:masterClrMapping/>
+  </p:clrMapOvr>
+</p:sld>
+</file>
+
+<file path=ppt/slides/slide6.xml><?xml version="1.0" encoding="utf-8"?>
+<p:sld xmlns:a="http://schemas.openxmlformats.org/drawingml/2006/main" xmlns:p="http://schemas.openxmlformats.org/presentationml/2006/main" xmlns:r="http://schemas.openxmlformats.org/officeDocument/2006/relationships">
+  <p:cSld>
+    <p:spTree>
+      <p:nvGrpSpPr>
+        <p:cNvPr id="1" name=""/>
+        <p:cNvGrpSpPr/>
+        <p:nvPr/>
+      </p:nvGrpSpPr>
+      <p:grpSpPr/>
+      <p:sp>
+        <p:nvSpPr>
+          <p:cNvPr id="2" name="Title 1"/>
+          <p:cNvSpPr>
+            <a:spLocks noGrp="1"/>
+          </p:cNvSpPr>
+          <p:nvPr>
+            <p:ph type="title"/>
+          </p:nvPr>
+        </p:nvSpPr>
+        <p:spPr/>
+        <p:txBody>
+          <a:bodyPr/>
+          <a:lstStyle/>
+          <a:p>
+            <a:r>
+              <a:t>GitHub Repository &amp; Deliverables</a:t>
+            </a:r>
+          </a:p>
+        </p:txBody>
+      </p:sp>
+      <p:sp>
+        <p:nvSpPr>
+          <p:cNvPr id="3" name="Content Placeholder 2"/>
+          <p:cNvSpPr>
+            <a:spLocks noGrp="1"/>
+          </p:cNvSpPr>
+          <p:nvPr>
+            <p:ph idx="1"/>
+          </p:nvPr>
+        </p:nvSpPr>
+        <p:spPr/>
+        <p:txBody>
+          <a:bodyPr/>
+          <a:lstStyle/>
+          <a:p>
+            <a:r>
+              <a:t>Open Source Project Repository</a:t>
+            </a:r>
+          </a:p>
+          <a:p>
+            <a:pPr lvl="1"/>
+            <a:r>
+              <a:t>GitHub URL: https://github.com/Rudraxtyagii/CropCare-AI</a:t>
+            </a:r>
+          </a:p>
+          <a:p>
+            <a:pPr lvl="1"/>
+            <a:r>
+              <a:t>AI/ML Codebase: train.py, inference.py, and 38-class botanical knowledge base.</a:t>
+            </a:r>
+          </a:p>
+          <a:p>
+            <a:pPr lvl="1"/>
+            <a:r>
+              <a:t>Production Server: main.py (FastAPI) with CORS and Pydantic validation.</a:t>
+            </a:r>
+          </a:p>
+          <a:p>
+            <a:pPr lvl="1"/>
+            <a:r>
+              <a:t>Documentation: Technical Report, Verification QA Report, Title Page, and Summary PDF.</a:t>
+            </a:r>
+          </a:p>
+        </p:txBody>
+      </p:sp>
+    </p:spTree>
+  </p:cSld>
+  <p:clrMapOvr>
+    <a:masterClrMapping/>
+  </p:clrMapOvr>
+</p:sld>
+</file>
+
+<file path=ppt/slides/slide7.xml><?xml version="1.0" encoding="utf-8"?>
 <p:sld xmlns:a="http://schemas.openxmlformats.org/drawingml/2006/main" xmlns:p="http://schemas.openxmlformats.org/presentationml/2006/main" xmlns:r="http://schemas.openxmlformats.org/officeDocument/2006/relationships">
   <p:cSld>
     <p:spTree>

</xml_diff>